<commit_message>
Update Absolute Value Slide
</commit_message>
<xml_diff>
--- a/Session 02 - Python Fundamentals/Session 02 - Python Fundamentals.pptx
+++ b/Session 02 - Python Fundamentals/Session 02 - Python Fundamentals.pptx
@@ -5,10 +5,10 @@
     <p:sldMasterId id="2147483660" r:id="rId1"/>
   </p:sldMasterIdLst>
   <p:notesMasterIdLst>
-    <p:notesMasterId r:id="rId39"/>
+    <p:notesMasterId r:id="rId40"/>
   </p:notesMasterIdLst>
   <p:handoutMasterIdLst>
-    <p:handoutMasterId r:id="rId40"/>
+    <p:handoutMasterId r:id="rId41"/>
   </p:handoutMasterIdLst>
   <p:sldIdLst>
     <p:sldId id="1220" r:id="rId2"/>
@@ -35,19 +35,20 @@
     <p:sldId id="1235" r:id="rId23"/>
     <p:sldId id="1365" r:id="rId24"/>
     <p:sldId id="1264" r:id="rId25"/>
-    <p:sldId id="1299" r:id="rId26"/>
-    <p:sldId id="1363" r:id="rId27"/>
-    <p:sldId id="1291" r:id="rId28"/>
-    <p:sldId id="1284" r:id="rId29"/>
-    <p:sldId id="1364" r:id="rId30"/>
-    <p:sldId id="1281" r:id="rId31"/>
-    <p:sldId id="412" r:id="rId32"/>
-    <p:sldId id="1348" r:id="rId33"/>
-    <p:sldId id="983" r:id="rId34"/>
-    <p:sldId id="1362" r:id="rId35"/>
-    <p:sldId id="415" r:id="rId36"/>
-    <p:sldId id="416" r:id="rId37"/>
-    <p:sldId id="995" r:id="rId38"/>
+    <p:sldId id="1271" r:id="rId26"/>
+    <p:sldId id="1299" r:id="rId27"/>
+    <p:sldId id="1363" r:id="rId28"/>
+    <p:sldId id="1291" r:id="rId29"/>
+    <p:sldId id="1284" r:id="rId30"/>
+    <p:sldId id="1364" r:id="rId31"/>
+    <p:sldId id="1281" r:id="rId32"/>
+    <p:sldId id="412" r:id="rId33"/>
+    <p:sldId id="1348" r:id="rId34"/>
+    <p:sldId id="983" r:id="rId35"/>
+    <p:sldId id="1362" r:id="rId36"/>
+    <p:sldId id="415" r:id="rId37"/>
+    <p:sldId id="416" r:id="rId38"/>
+    <p:sldId id="995" r:id="rId39"/>
   </p:sldIdLst>
   <p:sldSz cx="9144000" cy="6858000" type="screen4x3"/>
   <p:notesSz cx="7077075" cy="9363075"/>
@@ -295,7 +296,7 @@
           <a:p>
             <a:fld id="{A241AC98-512A-4A35-865E-757B6C1F07A2}" type="datetimeFigureOut">
               <a:rPr lang="en-US" smtClean="0"/>
-              <a:t>11/20/2025</a:t>
+              <a:t>12/18/2025</a:t>
             </a:fld>
             <a:endParaRPr lang="en-US"/>
           </a:p>
@@ -461,7 +462,7 @@
           <a:p>
             <a:fld id="{3854CEE7-15DE-41D9-8CA2-D1E137B1D850}" type="datetimeFigureOut">
               <a:rPr lang="en-US" smtClean="0"/>
-              <a:t>11/20/2025</a:t>
+              <a:t>12/18/2025</a:t>
             </a:fld>
             <a:endParaRPr lang="en-US"/>
           </a:p>
@@ -757,6 +758,13 @@
           </p:nvPr>
         </p:nvSpPr>
         <p:spPr/>
+        <p:txBody>
+          <a:bodyPr/>
+          <a:lstStyle/>
+          <a:p>
+            <a:endParaRPr lang="en-US"/>
+          </a:p>
+        </p:txBody>
       </p:sp>
       <p:sp>
         <p:nvSpPr>
@@ -841,6 +849,13 @@
           </p:nvPr>
         </p:nvSpPr>
         <p:spPr/>
+        <p:txBody>
+          <a:bodyPr/>
+          <a:lstStyle/>
+          <a:p>
+            <a:endParaRPr lang="en-US"/>
+          </a:p>
+        </p:txBody>
       </p:sp>
       <p:sp>
         <p:nvSpPr>
@@ -1028,7 +1043,7 @@
           <a:p>
             <a:fld id="{5555EB2C-244D-4423-AD97-018ED6478B87}" type="datetime1">
               <a:rPr lang="en-US" smtClean="0"/>
-              <a:t>11/20/2025</a:t>
+              <a:t>12/18/2025</a:t>
             </a:fld>
             <a:endParaRPr lang="en-US"/>
           </a:p>
@@ -1207,7 +1222,7 @@
           <a:p>
             <a:fld id="{A2B41D1F-7576-4C60-B4EB-5115BC56CF40}" type="datetime1">
               <a:rPr lang="en-US" smtClean="0"/>
-              <a:t>11/20/2025</a:t>
+              <a:t>12/18/2025</a:t>
             </a:fld>
             <a:endParaRPr lang="en-US"/>
           </a:p>
@@ -1399,7 +1414,7 @@
           <a:p>
             <a:fld id="{E79D1398-4D56-44F9-BA35-34ACF3159A64}" type="datetime1">
               <a:rPr lang="en-US" smtClean="0"/>
-              <a:t>11/20/2025</a:t>
+              <a:t>12/18/2025</a:t>
             </a:fld>
             <a:endParaRPr lang="en-US"/>
           </a:p>
@@ -1581,7 +1596,7 @@
           <a:p>
             <a:fld id="{A3CF632E-48CB-4EEB-A6B6-DEC7AD7CC976}" type="datetime1">
               <a:rPr lang="en-US" smtClean="0"/>
-              <a:t>11/20/2025</a:t>
+              <a:t>12/18/2025</a:t>
             </a:fld>
             <a:endParaRPr lang="en-US"/>
           </a:p>
@@ -1834,7 +1849,7 @@
           <a:p>
             <a:fld id="{BAEEE52C-3A57-458E-95F6-96B2FA9D1DD4}" type="datetime1">
               <a:rPr lang="en-US" smtClean="0"/>
-              <a:t>11/20/2025</a:t>
+              <a:t>12/18/2025</a:t>
             </a:fld>
             <a:endParaRPr lang="en-US"/>
           </a:p>
@@ -2078,7 +2093,7 @@
           <a:p>
             <a:fld id="{766FC747-A48A-4FF2-8EE4-3E95ECD1C2A8}" type="datetime1">
               <a:rPr lang="en-US" smtClean="0"/>
-              <a:t>11/20/2025</a:t>
+              <a:t>12/18/2025</a:t>
             </a:fld>
             <a:endParaRPr lang="en-US"/>
           </a:p>
@@ -2457,7 +2472,7 @@
           <a:p>
             <a:fld id="{C9BF5758-AB7F-463D-B638-E1729B95E126}" type="datetime1">
               <a:rPr lang="en-US" smtClean="0"/>
-              <a:t>11/20/2025</a:t>
+              <a:t>12/18/2025</a:t>
             </a:fld>
             <a:endParaRPr lang="en-US"/>
           </a:p>
@@ -2587,7 +2602,7 @@
           <a:p>
             <a:fld id="{F3718C77-7DD0-4738-BF52-D0EC9F78A76E}" type="datetime1">
               <a:rPr lang="en-US" smtClean="0"/>
-              <a:t>11/20/2025</a:t>
+              <a:t>12/18/2025</a:t>
             </a:fld>
             <a:endParaRPr lang="en-US"/>
           </a:p>
@@ -2694,7 +2709,7 @@
           <a:p>
             <a:fld id="{948970CF-13D9-4E1D-A74F-2CFE4953FCDB}" type="datetime1">
               <a:rPr lang="en-US" smtClean="0"/>
-              <a:t>11/20/2025</a:t>
+              <a:t>12/18/2025</a:t>
             </a:fld>
             <a:endParaRPr lang="en-US"/>
           </a:p>
@@ -2983,7 +2998,7 @@
           <a:p>
             <a:fld id="{F68C49B9-4E1C-4967-B9CF-0BF9FECBE837}" type="datetime1">
               <a:rPr lang="en-US" smtClean="0"/>
-              <a:t>11/20/2025</a:t>
+              <a:t>12/18/2025</a:t>
             </a:fld>
             <a:endParaRPr lang="en-US"/>
           </a:p>
@@ -3251,7 +3266,7 @@
           <a:p>
             <a:fld id="{7E338CBB-1F06-4333-9BBF-66628B15E581}" type="datetime1">
               <a:rPr lang="en-US" smtClean="0"/>
-              <a:t>11/20/2025</a:t>
+              <a:t>12/18/2025</a:t>
             </a:fld>
             <a:endParaRPr lang="en-US"/>
           </a:p>
@@ -3476,7 +3491,7 @@
           <a:p>
             <a:fld id="{705EC883-F03C-4CA3-AF62-BEF30EEA4F65}" type="datetime1">
               <a:rPr lang="en-US" smtClean="0"/>
-              <a:t>11/20/2025</a:t>
+              <a:t>12/18/2025</a:t>
             </a:fld>
             <a:endParaRPr lang="en-US"/>
           </a:p>
@@ -18990,6 +19005,224 @@
       </p:grpSpPr>
       <p:pic>
         <p:nvPicPr>
+          <p:cNvPr id="5" name="Picture 4">
+            <a:extLst>
+              <a:ext uri="{FF2B5EF4-FFF2-40B4-BE49-F238E27FC236}">
+                <a16:creationId xmlns:a16="http://schemas.microsoft.com/office/drawing/2014/main" id="{9675ABEB-DF72-A729-25B7-225C22544610}"/>
+              </a:ext>
+            </a:extLst>
+          </p:cNvPr>
+          <p:cNvPicPr>
+            <a:picLocks noChangeAspect="1"/>
+          </p:cNvPicPr>
+          <p:nvPr/>
+        </p:nvPicPr>
+        <p:blipFill>
+          <a:blip r:embed="rId2"/>
+          <a:stretch>
+            <a:fillRect/>
+          </a:stretch>
+        </p:blipFill>
+        <p:spPr>
+          <a:xfrm>
+            <a:off x="959370" y="1897287"/>
+            <a:ext cx="7225259" cy="4681503"/>
+          </a:xfrm>
+          <a:prstGeom prst="rect">
+            <a:avLst/>
+          </a:prstGeom>
+          <a:ln>
+            <a:solidFill>
+              <a:schemeClr val="tx1"/>
+            </a:solidFill>
+          </a:ln>
+        </p:spPr>
+      </p:pic>
+      <p:sp>
+        <p:nvSpPr>
+          <p:cNvPr id="2" name="Title 1"/>
+          <p:cNvSpPr>
+            <a:spLocks noGrp="1"/>
+          </p:cNvSpPr>
+          <p:nvPr>
+            <p:ph type="title"/>
+          </p:nvPr>
+        </p:nvSpPr>
+        <p:spPr/>
+        <p:txBody>
+          <a:bodyPr>
+            <a:noAutofit/>
+          </a:bodyPr>
+          <a:lstStyle/>
+          <a:p>
+            <a:pPr algn="ctr"/>
+            <a:r>
+              <a:rPr lang="en-US" sz="3200" dirty="0">
+                <a:latin typeface="+mn-lt"/>
+              </a:rPr>
+              <a:t>The </a:t>
+            </a:r>
+            <a:r>
+              <a:rPr lang="en-US" sz="3200" b="1" dirty="0">
+                <a:latin typeface="+mn-lt"/>
+              </a:rPr>
+              <a:t>black</a:t>
+            </a:r>
+            <a:r>
+              <a:rPr lang="en-US" sz="3200" dirty="0">
+                <a:latin typeface="+mn-lt"/>
+              </a:rPr>
+              <a:t> Package</a:t>
+            </a:r>
+          </a:p>
+        </p:txBody>
+      </p:sp>
+      <p:sp>
+        <p:nvSpPr>
+          <p:cNvPr id="3" name="Slide Number Placeholder 2"/>
+          <p:cNvSpPr>
+            <a:spLocks noGrp="1"/>
+          </p:cNvSpPr>
+          <p:nvPr>
+            <p:ph type="sldNum" sz="quarter" idx="12"/>
+          </p:nvPr>
+        </p:nvSpPr>
+        <p:spPr/>
+        <p:txBody>
+          <a:bodyPr/>
+          <a:lstStyle/>
+          <a:p>
+            <a:fld id="{650AD656-6FF9-465D-B7B0-1CD0DD39CD23}" type="slidenum">
+              <a:rPr lang="en-US" smtClean="0"/>
+              <a:t>25</a:t>
+            </a:fld>
+            <a:endParaRPr lang="en-US" dirty="0"/>
+          </a:p>
+        </p:txBody>
+      </p:sp>
+      <p:sp>
+        <p:nvSpPr>
+          <p:cNvPr id="10" name="TextBox 9">
+            <a:extLst>
+              <a:ext uri="{FF2B5EF4-FFF2-40B4-BE49-F238E27FC236}">
+                <a16:creationId xmlns:a16="http://schemas.microsoft.com/office/drawing/2014/main" id="{7EA28FBA-9A18-C43F-0200-822C69EF5FA4}"/>
+              </a:ext>
+            </a:extLst>
+          </p:cNvPr>
+          <p:cNvSpPr txBox="1"/>
+          <p:nvPr/>
+        </p:nvSpPr>
+        <p:spPr>
+          <a:xfrm>
+            <a:off x="2973674" y="1402598"/>
+            <a:ext cx="3196653" cy="369332"/>
+          </a:xfrm>
+          <a:prstGeom prst="rect">
+            <a:avLst/>
+          </a:prstGeom>
+          <a:noFill/>
+        </p:spPr>
+        <p:txBody>
+          <a:bodyPr wrap="square">
+            <a:spAutoFit/>
+          </a:bodyPr>
+          <a:lstStyle/>
+          <a:p>
+            <a:pPr algn="ctr"/>
+            <a:r>
+              <a:rPr lang="en-US" dirty="0">
+                <a:hlinkClick r:id="rId3"/>
+              </a:rPr>
+              <a:t>https://github.com/psf/black</a:t>
+            </a:r>
+            <a:endParaRPr lang="en-US" dirty="0"/>
+          </a:p>
+        </p:txBody>
+      </p:sp>
+      <p:sp>
+        <p:nvSpPr>
+          <p:cNvPr id="11" name="Rectangle 10">
+            <a:extLst>
+              <a:ext uri="{FF2B5EF4-FFF2-40B4-BE49-F238E27FC236}">
+                <a16:creationId xmlns:a16="http://schemas.microsoft.com/office/drawing/2014/main" id="{758E6D21-0922-B1D6-3F20-C56734F729BB}"/>
+              </a:ext>
+            </a:extLst>
+          </p:cNvPr>
+          <p:cNvSpPr/>
+          <p:nvPr/>
+        </p:nvSpPr>
+        <p:spPr>
+          <a:xfrm>
+            <a:off x="2870617" y="3918588"/>
+            <a:ext cx="3507698" cy="323628"/>
+          </a:xfrm>
+          <a:prstGeom prst="rect">
+            <a:avLst/>
+          </a:prstGeom>
+          <a:noFill/>
+          <a:ln w="28575">
+            <a:solidFill>
+              <a:srgbClr val="FF0000"/>
+            </a:solidFill>
+          </a:ln>
+        </p:spPr>
+        <p:style>
+          <a:lnRef idx="2">
+            <a:schemeClr val="accent1">
+              <a:shade val="15000"/>
+            </a:schemeClr>
+          </a:lnRef>
+          <a:fillRef idx="1">
+            <a:schemeClr val="accent1"/>
+          </a:fillRef>
+          <a:effectRef idx="0">
+            <a:schemeClr val="accent1"/>
+          </a:effectRef>
+          <a:fontRef idx="minor">
+            <a:schemeClr val="lt1"/>
+          </a:fontRef>
+        </p:style>
+        <p:txBody>
+          <a:bodyPr rtlCol="0" anchor="ctr"/>
+          <a:lstStyle/>
+          <a:p>
+            <a:pPr algn="ctr"/>
+            <a:endParaRPr lang="en-US"/>
+          </a:p>
+        </p:txBody>
+      </p:sp>
+    </p:spTree>
+    <p:extLst>
+      <p:ext uri="{BB962C8B-B14F-4D97-AF65-F5344CB8AC3E}">
+        <p14:creationId xmlns:p14="http://schemas.microsoft.com/office/powerpoint/2010/main" val="1437037177"/>
+      </p:ext>
+    </p:extLst>
+  </p:cSld>
+  <p:clrMapOvr>
+    <a:masterClrMapping/>
+  </p:clrMapOvr>
+</p:sld>
+</file>
+
+<file path=ppt/slides/slide26.xml><?xml version="1.0" encoding="utf-8"?>
+<p:sld xmlns:a="http://schemas.openxmlformats.org/drawingml/2006/main" xmlns:r="http://schemas.openxmlformats.org/officeDocument/2006/relationships" xmlns:p="http://schemas.openxmlformats.org/presentationml/2006/main">
+  <p:cSld>
+    <p:spTree>
+      <p:nvGrpSpPr>
+        <p:cNvPr id="1" name=""/>
+        <p:cNvGrpSpPr/>
+        <p:nvPr/>
+      </p:nvGrpSpPr>
+      <p:grpSpPr>
+        <a:xfrm>
+          <a:off x="0" y="0"/>
+          <a:ext cx="0" cy="0"/>
+          <a:chOff x="0" y="0"/>
+          <a:chExt cx="0" cy="0"/>
+        </a:xfrm>
+      </p:grpSpPr>
+      <p:pic>
+        <p:nvPicPr>
           <p:cNvPr id="8" name="Picture 7">
             <a:extLst>
               <a:ext uri="{FF2B5EF4-FFF2-40B4-BE49-F238E27FC236}">
@@ -19086,7 +19319,7 @@
           <a:p>
             <a:fld id="{650AD656-6FF9-465D-B7B0-1CD0DD39CD23}" type="slidenum">
               <a:rPr lang="en-US" smtClean="0"/>
-              <a:t>25</a:t>
+              <a:t>26</a:t>
             </a:fld>
             <a:endParaRPr lang="en-US" dirty="0"/>
           </a:p>
@@ -19144,7 +19377,7 @@
 </p:sld>
 </file>
 
-<file path=ppt/slides/slide26.xml><?xml version="1.0" encoding="utf-8"?>
+<file path=ppt/slides/slide27.xml><?xml version="1.0" encoding="utf-8"?>
 <p:sld xmlns:a="http://schemas.openxmlformats.org/drawingml/2006/main" xmlns:r="http://schemas.openxmlformats.org/officeDocument/2006/relationships" xmlns:p="http://schemas.openxmlformats.org/presentationml/2006/main">
   <p:cSld>
     <p:spTree>
@@ -19277,7 +19510,7 @@
           <a:p>
             <a:fld id="{650AD656-6FF9-465D-B7B0-1CD0DD39CD23}" type="slidenum">
               <a:rPr lang="en-US" smtClean="0"/>
-              <a:t>26</a:t>
+              <a:t>27</a:t>
             </a:fld>
             <a:endParaRPr lang="en-US" dirty="0"/>
           </a:p>
@@ -20820,7 +21053,7 @@
 </p:sld>
 </file>
 
-<file path=ppt/slides/slide27.xml><?xml version="1.0" encoding="utf-8"?>
+<file path=ppt/slides/slide28.xml><?xml version="1.0" encoding="utf-8"?>
 <p:sld xmlns:a="http://schemas.openxmlformats.org/drawingml/2006/main" xmlns:r="http://schemas.openxmlformats.org/officeDocument/2006/relationships" xmlns:p="http://schemas.openxmlformats.org/presentationml/2006/main">
   <p:cSld>
     <p:spTree>
@@ -21231,7 +21464,7 @@
           <a:p>
             <a:fld id="{650AD656-6FF9-465D-B7B0-1CD0DD39CD23}" type="slidenum">
               <a:rPr lang="en-US" smtClean="0"/>
-              <a:t>27</a:t>
+              <a:t>28</a:t>
             </a:fld>
             <a:endParaRPr lang="en-US" dirty="0"/>
           </a:p>
@@ -22064,7 +22297,7 @@
 </p:sld>
 </file>
 
-<file path=ppt/slides/slide28.xml><?xml version="1.0" encoding="utf-8"?>
+<file path=ppt/slides/slide29.xml><?xml version="1.0" encoding="utf-8"?>
 <p:sld xmlns:a="http://schemas.openxmlformats.org/drawingml/2006/main" xmlns:r="http://schemas.openxmlformats.org/officeDocument/2006/relationships" xmlns:p="http://schemas.openxmlformats.org/presentationml/2006/main">
   <p:cSld>
     <p:spTree>
@@ -22139,7 +22372,7 @@
           <a:p>
             <a:fld id="{650AD656-6FF9-465D-B7B0-1CD0DD39CD23}" type="slidenum">
               <a:rPr lang="en-US" smtClean="0"/>
-              <a:t>28</a:t>
+              <a:t>29</a:t>
             </a:fld>
             <a:endParaRPr lang="en-US" dirty="0"/>
           </a:p>
@@ -22535,148 +22768,6 @@
 </p:sld>
 </file>
 
-<file path=ppt/slides/slide29.xml><?xml version="1.0" encoding="utf-8"?>
-<p:sld xmlns:a="http://schemas.openxmlformats.org/drawingml/2006/main" xmlns:r="http://schemas.openxmlformats.org/officeDocument/2006/relationships" xmlns:p="http://schemas.openxmlformats.org/presentationml/2006/main">
-  <p:cSld>
-    <p:spTree>
-      <p:nvGrpSpPr>
-        <p:cNvPr id="1" name="">
-          <a:extLst>
-            <a:ext uri="{FF2B5EF4-FFF2-40B4-BE49-F238E27FC236}">
-              <a16:creationId xmlns:a16="http://schemas.microsoft.com/office/drawing/2014/main" id="{14B73195-25D6-581B-02F0-E5B483A0B4D4}"/>
-            </a:ext>
-          </a:extLst>
-        </p:cNvPr>
-        <p:cNvGrpSpPr/>
-        <p:nvPr/>
-      </p:nvGrpSpPr>
-      <p:grpSpPr>
-        <a:xfrm>
-          <a:off x="0" y="0"/>
-          <a:ext cx="0" cy="0"/>
-          <a:chOff x="0" y="0"/>
-          <a:chExt cx="0" cy="0"/>
-        </a:xfrm>
-      </p:grpSpPr>
-      <p:sp>
-        <p:nvSpPr>
-          <p:cNvPr id="2" name="Title 1">
-            <a:extLst>
-              <a:ext uri="{FF2B5EF4-FFF2-40B4-BE49-F238E27FC236}">
-                <a16:creationId xmlns:a16="http://schemas.microsoft.com/office/drawing/2014/main" id="{E3AC9D3C-CF6A-B81C-2BD6-7E1EB3EBB1BC}"/>
-              </a:ext>
-            </a:extLst>
-          </p:cNvPr>
-          <p:cNvSpPr>
-            <a:spLocks noGrp="1"/>
-          </p:cNvSpPr>
-          <p:nvPr>
-            <p:ph type="title"/>
-          </p:nvPr>
-        </p:nvSpPr>
-        <p:spPr>
-          <a:xfrm>
-            <a:off x="628650" y="365126"/>
-            <a:ext cx="7886700" cy="1103455"/>
-          </a:xfrm>
-        </p:spPr>
-        <p:txBody>
-          <a:bodyPr>
-            <a:noAutofit/>
-          </a:bodyPr>
-          <a:lstStyle/>
-          <a:p>
-            <a:pPr algn="ctr"/>
-            <a:r>
-              <a:rPr lang="en-US" sz="3200" b="1" dirty="0">
-                <a:solidFill>
-                  <a:srgbClr val="7030A0"/>
-                </a:solidFill>
-                <a:latin typeface="+mn-lt"/>
-              </a:rPr>
-              <a:t>for</a:t>
-            </a:r>
-            <a:r>
-              <a:rPr lang="en-US" sz="3200" dirty="0">
-                <a:latin typeface="+mn-lt"/>
-              </a:rPr>
-              <a:t> loops</a:t>
-            </a:r>
-          </a:p>
-        </p:txBody>
-      </p:sp>
-      <p:sp>
-        <p:nvSpPr>
-          <p:cNvPr id="7" name="Slide Number Placeholder 6">
-            <a:extLst>
-              <a:ext uri="{FF2B5EF4-FFF2-40B4-BE49-F238E27FC236}">
-                <a16:creationId xmlns:a16="http://schemas.microsoft.com/office/drawing/2014/main" id="{F2CCBF58-9D0F-97F5-6A8B-C19376C82B54}"/>
-              </a:ext>
-            </a:extLst>
-          </p:cNvPr>
-          <p:cNvSpPr>
-            <a:spLocks noGrp="1"/>
-          </p:cNvSpPr>
-          <p:nvPr>
-            <p:ph type="sldNum" sz="quarter" idx="12"/>
-          </p:nvPr>
-        </p:nvSpPr>
-        <p:spPr/>
-        <p:txBody>
-          <a:bodyPr/>
-          <a:lstStyle/>
-          <a:p>
-            <a:fld id="{650AD656-6FF9-465D-B7B0-1CD0DD39CD23}" type="slidenum">
-              <a:rPr lang="en-US" smtClean="0"/>
-              <a:t>29</a:t>
-            </a:fld>
-            <a:endParaRPr lang="en-US" dirty="0"/>
-          </a:p>
-        </p:txBody>
-      </p:sp>
-      <p:pic>
-        <p:nvPicPr>
-          <p:cNvPr id="3" name="Picture 2">
-            <a:extLst>
-              <a:ext uri="{FF2B5EF4-FFF2-40B4-BE49-F238E27FC236}">
-                <a16:creationId xmlns:a16="http://schemas.microsoft.com/office/drawing/2014/main" id="{A29D8BC3-F02D-BB62-0367-AA78ED34F4B0}"/>
-              </a:ext>
-            </a:extLst>
-          </p:cNvPr>
-          <p:cNvPicPr>
-            <a:picLocks noChangeAspect="1"/>
-          </p:cNvPicPr>
-          <p:nvPr/>
-        </p:nvPicPr>
-        <p:blipFill>
-          <a:blip r:embed="rId2"/>
-          <a:stretch>
-            <a:fillRect/>
-          </a:stretch>
-        </p:blipFill>
-        <p:spPr>
-          <a:xfrm>
-            <a:off x="573505" y="1382373"/>
-            <a:ext cx="7996989" cy="4703746"/>
-          </a:xfrm>
-          <a:prstGeom prst="rect">
-            <a:avLst/>
-          </a:prstGeom>
-        </p:spPr>
-      </p:pic>
-    </p:spTree>
-    <p:extLst>
-      <p:ext uri="{BB962C8B-B14F-4D97-AF65-F5344CB8AC3E}">
-        <p14:creationId xmlns:p14="http://schemas.microsoft.com/office/powerpoint/2010/main" val="476521684"/>
-      </p:ext>
-    </p:extLst>
-  </p:cSld>
-  <p:clrMapOvr>
-    <a:masterClrMapping/>
-  </p:clrMapOvr>
-</p:sld>
-</file>
-
 <file path=ppt/slides/slide3.xml><?xml version="1.0" encoding="utf-8"?>
 <p:sld xmlns:a="http://schemas.openxmlformats.org/drawingml/2006/main" xmlns:r="http://schemas.openxmlformats.org/officeDocument/2006/relationships" xmlns:p="http://schemas.openxmlformats.org/presentationml/2006/main">
   <p:cSld>
@@ -22849,6 +22940,148 @@
   <p:cSld>
     <p:spTree>
       <p:nvGrpSpPr>
+        <p:cNvPr id="1" name="">
+          <a:extLst>
+            <a:ext uri="{FF2B5EF4-FFF2-40B4-BE49-F238E27FC236}">
+              <a16:creationId xmlns:a16="http://schemas.microsoft.com/office/drawing/2014/main" id="{14B73195-25D6-581B-02F0-E5B483A0B4D4}"/>
+            </a:ext>
+          </a:extLst>
+        </p:cNvPr>
+        <p:cNvGrpSpPr/>
+        <p:nvPr/>
+      </p:nvGrpSpPr>
+      <p:grpSpPr>
+        <a:xfrm>
+          <a:off x="0" y="0"/>
+          <a:ext cx="0" cy="0"/>
+          <a:chOff x="0" y="0"/>
+          <a:chExt cx="0" cy="0"/>
+        </a:xfrm>
+      </p:grpSpPr>
+      <p:sp>
+        <p:nvSpPr>
+          <p:cNvPr id="2" name="Title 1">
+            <a:extLst>
+              <a:ext uri="{FF2B5EF4-FFF2-40B4-BE49-F238E27FC236}">
+                <a16:creationId xmlns:a16="http://schemas.microsoft.com/office/drawing/2014/main" id="{E3AC9D3C-CF6A-B81C-2BD6-7E1EB3EBB1BC}"/>
+              </a:ext>
+            </a:extLst>
+          </p:cNvPr>
+          <p:cNvSpPr>
+            <a:spLocks noGrp="1"/>
+          </p:cNvSpPr>
+          <p:nvPr>
+            <p:ph type="title"/>
+          </p:nvPr>
+        </p:nvSpPr>
+        <p:spPr>
+          <a:xfrm>
+            <a:off x="628650" y="365126"/>
+            <a:ext cx="7886700" cy="1103455"/>
+          </a:xfrm>
+        </p:spPr>
+        <p:txBody>
+          <a:bodyPr>
+            <a:noAutofit/>
+          </a:bodyPr>
+          <a:lstStyle/>
+          <a:p>
+            <a:pPr algn="ctr"/>
+            <a:r>
+              <a:rPr lang="en-US" sz="3200" b="1" dirty="0">
+                <a:solidFill>
+                  <a:srgbClr val="7030A0"/>
+                </a:solidFill>
+                <a:latin typeface="+mn-lt"/>
+              </a:rPr>
+              <a:t>for</a:t>
+            </a:r>
+            <a:r>
+              <a:rPr lang="en-US" sz="3200" dirty="0">
+                <a:latin typeface="+mn-lt"/>
+              </a:rPr>
+              <a:t> loops</a:t>
+            </a:r>
+          </a:p>
+        </p:txBody>
+      </p:sp>
+      <p:sp>
+        <p:nvSpPr>
+          <p:cNvPr id="7" name="Slide Number Placeholder 6">
+            <a:extLst>
+              <a:ext uri="{FF2B5EF4-FFF2-40B4-BE49-F238E27FC236}">
+                <a16:creationId xmlns:a16="http://schemas.microsoft.com/office/drawing/2014/main" id="{F2CCBF58-9D0F-97F5-6A8B-C19376C82B54}"/>
+              </a:ext>
+            </a:extLst>
+          </p:cNvPr>
+          <p:cNvSpPr>
+            <a:spLocks noGrp="1"/>
+          </p:cNvSpPr>
+          <p:nvPr>
+            <p:ph type="sldNum" sz="quarter" idx="12"/>
+          </p:nvPr>
+        </p:nvSpPr>
+        <p:spPr/>
+        <p:txBody>
+          <a:bodyPr/>
+          <a:lstStyle/>
+          <a:p>
+            <a:fld id="{650AD656-6FF9-465D-B7B0-1CD0DD39CD23}" type="slidenum">
+              <a:rPr lang="en-US" smtClean="0"/>
+              <a:t>30</a:t>
+            </a:fld>
+            <a:endParaRPr lang="en-US" dirty="0"/>
+          </a:p>
+        </p:txBody>
+      </p:sp>
+      <p:pic>
+        <p:nvPicPr>
+          <p:cNvPr id="3" name="Picture 2">
+            <a:extLst>
+              <a:ext uri="{FF2B5EF4-FFF2-40B4-BE49-F238E27FC236}">
+                <a16:creationId xmlns:a16="http://schemas.microsoft.com/office/drawing/2014/main" id="{A29D8BC3-F02D-BB62-0367-AA78ED34F4B0}"/>
+              </a:ext>
+            </a:extLst>
+          </p:cNvPr>
+          <p:cNvPicPr>
+            <a:picLocks noChangeAspect="1"/>
+          </p:cNvPicPr>
+          <p:nvPr/>
+        </p:nvPicPr>
+        <p:blipFill>
+          <a:blip r:embed="rId2"/>
+          <a:stretch>
+            <a:fillRect/>
+          </a:stretch>
+        </p:blipFill>
+        <p:spPr>
+          <a:xfrm>
+            <a:off x="573505" y="1382373"/>
+            <a:ext cx="7996989" cy="4703746"/>
+          </a:xfrm>
+          <a:prstGeom prst="rect">
+            <a:avLst/>
+          </a:prstGeom>
+        </p:spPr>
+      </p:pic>
+    </p:spTree>
+    <p:extLst>
+      <p:ext uri="{BB962C8B-B14F-4D97-AF65-F5344CB8AC3E}">
+        <p14:creationId xmlns:p14="http://schemas.microsoft.com/office/powerpoint/2010/main" val="476521684"/>
+      </p:ext>
+    </p:extLst>
+  </p:cSld>
+  <p:clrMapOvr>
+    <a:masterClrMapping/>
+  </p:clrMapOvr>
+</p:sld>
+</file>
+
+<file path=ppt/slides/slide31.xml><?xml version="1.0" encoding="utf-8"?>
+<p:sld xmlns:a="http://schemas.openxmlformats.org/drawingml/2006/main" xmlns:r="http://schemas.openxmlformats.org/officeDocument/2006/relationships" xmlns:p="http://schemas.openxmlformats.org/presentationml/2006/main">
+  <p:cSld>
+    <p:spTree>
+      <p:nvGrpSpPr>
         <p:cNvPr id="1" name=""/>
         <p:cNvGrpSpPr/>
         <p:nvPr/>
@@ -22878,7 +23111,7 @@
           <a:p>
             <a:fld id="{650AD656-6FF9-465D-B7B0-1CD0DD39CD23}" type="slidenum">
               <a:rPr lang="en-US" smtClean="0"/>
-              <a:t>30</a:t>
+              <a:t>31</a:t>
             </a:fld>
             <a:endParaRPr lang="en-US" dirty="0"/>
           </a:p>
@@ -23112,7 +23345,7 @@
 </p:sld>
 </file>
 
-<file path=ppt/slides/slide31.xml><?xml version="1.0" encoding="utf-8"?>
+<file path=ppt/slides/slide32.xml><?xml version="1.0" encoding="utf-8"?>
 <p:sld xmlns:a="http://schemas.openxmlformats.org/drawingml/2006/main" xmlns:r="http://schemas.openxmlformats.org/officeDocument/2006/relationships" xmlns:p="http://schemas.openxmlformats.org/presentationml/2006/main">
   <p:cSld>
     <p:spTree>
@@ -23357,7 +23590,7 @@
           <a:p>
             <a:fld id="{650AD656-6FF9-465D-B7B0-1CD0DD39CD23}" type="slidenum">
               <a:rPr lang="en-US" smtClean="0"/>
-              <a:t>31</a:t>
+              <a:t>32</a:t>
             </a:fld>
             <a:endParaRPr lang="en-US" dirty="0"/>
           </a:p>
@@ -23782,7 +24015,7 @@
 </p:sld>
 </file>
 
-<file path=ppt/slides/slide32.xml><?xml version="1.0" encoding="utf-8"?>
+<file path=ppt/slides/slide33.xml><?xml version="1.0" encoding="utf-8"?>
 <p:sld xmlns:a="http://schemas.openxmlformats.org/drawingml/2006/main" xmlns:r="http://schemas.openxmlformats.org/officeDocument/2006/relationships" xmlns:p="http://schemas.openxmlformats.org/presentationml/2006/main">
   <p:cSld>
     <p:spTree>
@@ -23901,7 +24134,7 @@
             <a:fld id="{650AD656-6FF9-465D-B7B0-1CD0DD39CD23}" type="slidenum">
               <a:rPr lang="en-US" smtClean="0"/>
               <a:pPr/>
-              <a:t>32</a:t>
+              <a:t>33</a:t>
             </a:fld>
             <a:endParaRPr lang="en-US"/>
           </a:p>
@@ -24647,7 +24880,7 @@
 </p:sld>
 </file>
 
-<file path=ppt/slides/slide33.xml><?xml version="1.0" encoding="utf-8"?>
+<file path=ppt/slides/slide34.xml><?xml version="1.0" encoding="utf-8"?>
 <p:sld xmlns:a="http://schemas.openxmlformats.org/drawingml/2006/main" xmlns:r="http://schemas.openxmlformats.org/officeDocument/2006/relationships" xmlns:p="http://schemas.openxmlformats.org/presentationml/2006/main">
   <p:cSld>
     <p:spTree>
@@ -24717,7 +24950,7 @@
           <a:p>
             <a:fld id="{650AD656-6FF9-465D-B7B0-1CD0DD39CD23}" type="slidenum">
               <a:rPr lang="en-US" smtClean="0"/>
-              <a:t>33</a:t>
+              <a:t>34</a:t>
             </a:fld>
             <a:endParaRPr lang="en-US" dirty="0"/>
           </a:p>
@@ -24906,7 +25139,7 @@
 </p:sld>
 </file>
 
-<file path=ppt/slides/slide34.xml><?xml version="1.0" encoding="utf-8"?>
+<file path=ppt/slides/slide35.xml><?xml version="1.0" encoding="utf-8"?>
 <p:sld xmlns:a="http://schemas.openxmlformats.org/drawingml/2006/main" xmlns:r="http://schemas.openxmlformats.org/officeDocument/2006/relationships" xmlns:p="http://schemas.openxmlformats.org/presentationml/2006/main">
   <p:cSld>
     <p:spTree>
@@ -24990,7 +25223,7 @@
           <a:p>
             <a:fld id="{650AD656-6FF9-465D-B7B0-1CD0DD39CD23}" type="slidenum">
               <a:rPr lang="en-US" smtClean="0"/>
-              <a:t>34</a:t>
+              <a:t>35</a:t>
             </a:fld>
             <a:endParaRPr lang="en-US" dirty="0"/>
           </a:p>
@@ -26605,7 +26838,7 @@
 </p:sld>
 </file>
 
-<file path=ppt/slides/slide35.xml><?xml version="1.0" encoding="utf-8"?>
+<file path=ppt/slides/slide36.xml><?xml version="1.0" encoding="utf-8"?>
 <p:sld xmlns:a="http://schemas.openxmlformats.org/drawingml/2006/main" xmlns:r="http://schemas.openxmlformats.org/officeDocument/2006/relationships" xmlns:p="http://schemas.openxmlformats.org/presentationml/2006/main">
   <p:cSld>
     <p:spTree>
@@ -26702,19 +26935,7 @@
               <a:rPr lang="en-US" sz="3200" dirty="0">
                 <a:latin typeface="+mn-lt"/>
               </a:rPr>
-              <a:t>(PV = </a:t>
-            </a:r>
-            <a:r>
-              <a:rPr lang="en-US" sz="3200" dirty="0" err="1">
-                <a:latin typeface="+mn-lt"/>
-              </a:rPr>
-              <a:t>nRT</a:t>
-            </a:r>
-            <a:r>
-              <a:rPr lang="en-US" sz="3200" dirty="0">
-                <a:latin typeface="+mn-lt"/>
-              </a:rPr>
-              <a:t>)</a:t>
+              <a:t>(PV = nRT)</a:t>
             </a:r>
           </a:p>
         </p:txBody>
@@ -26736,7 +26957,7 @@
           <a:p>
             <a:fld id="{650AD656-6FF9-465D-B7B0-1CD0DD39CD23}" type="slidenum">
               <a:rPr lang="en-US" smtClean="0"/>
-              <a:t>35</a:t>
+              <a:t>36</a:t>
             </a:fld>
             <a:endParaRPr lang="en-US" dirty="0"/>
           </a:p>
@@ -26959,8 +27180,8 @@
         </p:nvSpPr>
         <p:spPr>
           <a:xfrm>
-            <a:off x="484108" y="1444223"/>
-            <a:ext cx="2021305" cy="307777"/>
+            <a:off x="411918" y="1098575"/>
+            <a:ext cx="2507745" cy="307777"/>
           </a:xfrm>
           <a:prstGeom prst="rect">
             <a:avLst/>
@@ -26980,13 +27201,14 @@
           </a:bodyPr>
           <a:lstStyle/>
           <a:p>
+            <a:pPr algn="ctr"/>
             <a:r>
               <a:rPr lang="en-US" sz="1400" dirty="0">
                 <a:solidFill>
                   <a:srgbClr val="7030A0"/>
                 </a:solidFill>
               </a:rPr>
-              <a:t>Johann Heinrich Lambert</a:t>
+              <a:t>Johann Heinrich Lambert (1779)</a:t>
             </a:r>
           </a:p>
         </p:txBody>
@@ -27035,6 +27257,102 @@
           </a:fontRef>
         </p:style>
       </p:cxnSp>
+      <p:sp>
+        <p:nvSpPr>
+          <p:cNvPr id="5" name="TextBox 4">
+            <a:extLst>
+              <a:ext uri="{FF2B5EF4-FFF2-40B4-BE49-F238E27FC236}">
+                <a16:creationId xmlns:a16="http://schemas.microsoft.com/office/drawing/2014/main" id="{F0E2D892-C8D4-47CF-E7B9-9537DF19F82E}"/>
+              </a:ext>
+            </a:extLst>
+          </p:cNvPr>
+          <p:cNvSpPr txBox="1"/>
+          <p:nvPr/>
+        </p:nvSpPr>
+        <p:spPr>
+          <a:xfrm>
+            <a:off x="6757988" y="1021631"/>
+            <a:ext cx="2131969" cy="461665"/>
+          </a:xfrm>
+          <a:prstGeom prst="rect">
+            <a:avLst/>
+          </a:prstGeom>
+          <a:noFill/>
+        </p:spPr>
+        <p:txBody>
+          <a:bodyPr wrap="square" rtlCol="0">
+            <a:spAutoFit/>
+          </a:bodyPr>
+          <a:lstStyle/>
+          <a:p>
+            <a:r>
+              <a:rPr lang="en-US" sz="1200" i="1" dirty="0">
+                <a:solidFill>
+                  <a:srgbClr val="FF0000"/>
+                </a:solidFill>
+              </a:rPr>
+              <a:t>Jacques Charles (1787)</a:t>
+            </a:r>
+          </a:p>
+          <a:p>
+            <a:r>
+              <a:rPr lang="en-US" sz="1200" i="1" dirty="0">
+                <a:solidFill>
+                  <a:srgbClr val="FF0000"/>
+                </a:solidFill>
+              </a:rPr>
+              <a:t>Joseph Louis Gay-Lussac (1802) </a:t>
+            </a:r>
+          </a:p>
+        </p:txBody>
+      </p:sp>
+      <p:sp>
+        <p:nvSpPr>
+          <p:cNvPr id="12" name="TextBox 11">
+            <a:extLst>
+              <a:ext uri="{FF2B5EF4-FFF2-40B4-BE49-F238E27FC236}">
+                <a16:creationId xmlns:a16="http://schemas.microsoft.com/office/drawing/2014/main" id="{8EE0937E-8AF1-D0CD-1CBB-817FA507D700}"/>
+              </a:ext>
+            </a:extLst>
+          </p:cNvPr>
+          <p:cNvSpPr txBox="1"/>
+          <p:nvPr/>
+        </p:nvSpPr>
+        <p:spPr>
+          <a:xfrm>
+            <a:off x="1784522" y="2293412"/>
+            <a:ext cx="1763921" cy="307777"/>
+          </a:xfrm>
+          <a:prstGeom prst="rect">
+            <a:avLst/>
+          </a:prstGeom>
+          <a:solidFill>
+            <a:schemeClr val="bg1"/>
+          </a:solidFill>
+          <a:ln w="19050">
+            <a:solidFill>
+              <a:srgbClr val="7030A0"/>
+            </a:solidFill>
+          </a:ln>
+        </p:spPr>
+        <p:txBody>
+          <a:bodyPr wrap="square" rtlCol="0">
+            <a:spAutoFit/>
+          </a:bodyPr>
+          <a:lstStyle/>
+          <a:p>
+            <a:pPr algn="ctr"/>
+            <a:r>
+              <a:rPr lang="en-US" sz="1400" dirty="0">
+                <a:solidFill>
+                  <a:srgbClr val="7030A0"/>
+                </a:solidFill>
+              </a:rPr>
+              <a:t>“Air Thermometer”</a:t>
+            </a:r>
+          </a:p>
+        </p:txBody>
+      </p:sp>
     </p:spTree>
     <p:extLst>
       <p:ext uri="{BB962C8B-B14F-4D97-AF65-F5344CB8AC3E}">
@@ -27144,30 +27462,194 @@
                             </p:childTnLst>
                           </p:cTn>
                         </p:par>
-                      </p:childTnLst>
-                    </p:cTn>
-                  </p:par>
-                  <p:par>
-                    <p:cTn id="9" fill="hold">
-                      <p:stCondLst>
-                        <p:cond delay="indefinite"/>
-                      </p:stCondLst>
-                      <p:childTnLst>
                         <p:par>
-                          <p:cTn id="10" fill="hold">
+                          <p:cTn id="9" fill="hold">
                             <p:stCondLst>
-                              <p:cond delay="0"/>
+                              <p:cond delay="500"/>
                             </p:stCondLst>
                             <p:childTnLst>
                               <p:par>
-                                <p:cTn id="11" presetID="1" presetClass="entr" presetSubtype="0" fill="hold" nodeType="clickEffect">
+                                <p:cTn id="10" presetID="2" presetClass="entr" presetSubtype="1" fill="hold" grpId="0" nodeType="afterEffect">
                                   <p:stCondLst>
                                     <p:cond delay="0"/>
                                   </p:stCondLst>
                                   <p:childTnLst>
                                     <p:set>
                                       <p:cBhvr>
-                                        <p:cTn id="12" dur="1" fill="hold">
+                                        <p:cTn id="11" dur="1" fill="hold">
+                                          <p:stCondLst>
+                                            <p:cond delay="0"/>
+                                          </p:stCondLst>
+                                        </p:cTn>
+                                        <p:tgtEl>
+                                          <p:spTgt spid="5"/>
+                                        </p:tgtEl>
+                                        <p:attrNameLst>
+                                          <p:attrName>style.visibility</p:attrName>
+                                        </p:attrNameLst>
+                                      </p:cBhvr>
+                                      <p:to>
+                                        <p:strVal val="visible"/>
+                                      </p:to>
+                                    </p:set>
+                                    <p:anim calcmode="lin" valueType="num">
+                                      <p:cBhvr additive="base">
+                                        <p:cTn id="12" dur="500" fill="hold"/>
+                                        <p:tgtEl>
+                                          <p:spTgt spid="5"/>
+                                        </p:tgtEl>
+                                        <p:attrNameLst>
+                                          <p:attrName>ppt_x</p:attrName>
+                                        </p:attrNameLst>
+                                      </p:cBhvr>
+                                      <p:tavLst>
+                                        <p:tav tm="0">
+                                          <p:val>
+                                            <p:strVal val="#ppt_x"/>
+                                          </p:val>
+                                        </p:tav>
+                                        <p:tav tm="100000">
+                                          <p:val>
+                                            <p:strVal val="#ppt_x"/>
+                                          </p:val>
+                                        </p:tav>
+                                      </p:tavLst>
+                                    </p:anim>
+                                    <p:anim calcmode="lin" valueType="num">
+                                      <p:cBhvr additive="base">
+                                        <p:cTn id="13" dur="500" fill="hold"/>
+                                        <p:tgtEl>
+                                          <p:spTgt spid="5"/>
+                                        </p:tgtEl>
+                                        <p:attrNameLst>
+                                          <p:attrName>ppt_y</p:attrName>
+                                        </p:attrNameLst>
+                                      </p:cBhvr>
+                                      <p:tavLst>
+                                        <p:tav tm="0">
+                                          <p:val>
+                                            <p:strVal val="0-#ppt_h/2"/>
+                                          </p:val>
+                                        </p:tav>
+                                        <p:tav tm="100000">
+                                          <p:val>
+                                            <p:strVal val="#ppt_y"/>
+                                          </p:val>
+                                        </p:tav>
+                                      </p:tavLst>
+                                    </p:anim>
+                                  </p:childTnLst>
+                                </p:cTn>
+                              </p:par>
+                            </p:childTnLst>
+                          </p:cTn>
+                        </p:par>
+                        <p:par>
+                          <p:cTn id="14" fill="hold">
+                            <p:stCondLst>
+                              <p:cond delay="1000"/>
+                            </p:stCondLst>
+                            <p:childTnLst>
+                              <p:par>
+                                <p:cTn id="15" presetID="2" presetClass="entr" presetSubtype="1" fill="hold" grpId="0" nodeType="afterEffect">
+                                  <p:stCondLst>
+                                    <p:cond delay="0"/>
+                                  </p:stCondLst>
+                                  <p:childTnLst>
+                                    <p:set>
+                                      <p:cBhvr>
+                                        <p:cTn id="16" dur="1" fill="hold">
+                                          <p:stCondLst>
+                                            <p:cond delay="0"/>
+                                          </p:stCondLst>
+                                        </p:cTn>
+                                        <p:tgtEl>
+                                          <p:spTgt spid="12"/>
+                                        </p:tgtEl>
+                                        <p:attrNameLst>
+                                          <p:attrName>style.visibility</p:attrName>
+                                        </p:attrNameLst>
+                                      </p:cBhvr>
+                                      <p:to>
+                                        <p:strVal val="visible"/>
+                                      </p:to>
+                                    </p:set>
+                                    <p:anim calcmode="lin" valueType="num">
+                                      <p:cBhvr additive="base">
+                                        <p:cTn id="17" dur="500" fill="hold"/>
+                                        <p:tgtEl>
+                                          <p:spTgt spid="12"/>
+                                        </p:tgtEl>
+                                        <p:attrNameLst>
+                                          <p:attrName>ppt_x</p:attrName>
+                                        </p:attrNameLst>
+                                      </p:cBhvr>
+                                      <p:tavLst>
+                                        <p:tav tm="0">
+                                          <p:val>
+                                            <p:strVal val="#ppt_x"/>
+                                          </p:val>
+                                        </p:tav>
+                                        <p:tav tm="100000">
+                                          <p:val>
+                                            <p:strVal val="#ppt_x"/>
+                                          </p:val>
+                                        </p:tav>
+                                      </p:tavLst>
+                                    </p:anim>
+                                    <p:anim calcmode="lin" valueType="num">
+                                      <p:cBhvr additive="base">
+                                        <p:cTn id="18" dur="500" fill="hold"/>
+                                        <p:tgtEl>
+                                          <p:spTgt spid="12"/>
+                                        </p:tgtEl>
+                                        <p:attrNameLst>
+                                          <p:attrName>ppt_y</p:attrName>
+                                        </p:attrNameLst>
+                                      </p:cBhvr>
+                                      <p:tavLst>
+                                        <p:tav tm="0">
+                                          <p:val>
+                                            <p:strVal val="0-#ppt_h/2"/>
+                                          </p:val>
+                                        </p:tav>
+                                        <p:tav tm="100000">
+                                          <p:val>
+                                            <p:strVal val="#ppt_y"/>
+                                          </p:val>
+                                        </p:tav>
+                                      </p:tavLst>
+                                    </p:anim>
+                                  </p:childTnLst>
+                                </p:cTn>
+                              </p:par>
+                            </p:childTnLst>
+                          </p:cTn>
+                        </p:par>
+                      </p:childTnLst>
+                    </p:cTn>
+                  </p:par>
+                  <p:par>
+                    <p:cTn id="19" fill="hold">
+                      <p:stCondLst>
+                        <p:cond delay="indefinite"/>
+                      </p:stCondLst>
+                      <p:childTnLst>
+                        <p:par>
+                          <p:cTn id="20" fill="hold">
+                            <p:stCondLst>
+                              <p:cond delay="0"/>
+                            </p:stCondLst>
+                            <p:childTnLst>
+                              <p:par>
+                                <p:cTn id="21" presetID="1" presetClass="entr" presetSubtype="0" fill="hold" nodeType="clickEffect">
+                                  <p:stCondLst>
+                                    <p:cond delay="0"/>
+                                  </p:stCondLst>
+                                  <p:childTnLst>
+                                    <p:set>
+                                      <p:cBhvr>
+                                        <p:cTn id="22" dur="1" fill="hold">
                                           <p:stCondLst>
                                             <p:cond delay="0"/>
                                           </p:stCondLst>
@@ -27193,26 +27675,26 @@
                     </p:cTn>
                   </p:par>
                   <p:par>
-                    <p:cTn id="13" fill="hold">
+                    <p:cTn id="23" fill="hold">
                       <p:stCondLst>
                         <p:cond delay="indefinite"/>
                       </p:stCondLst>
                       <p:childTnLst>
                         <p:par>
-                          <p:cTn id="14" fill="hold">
+                          <p:cTn id="24" fill="hold">
                             <p:stCondLst>
                               <p:cond delay="0"/>
                             </p:stCondLst>
                             <p:childTnLst>
                               <p:par>
-                                <p:cTn id="15" presetID="22" presetClass="entr" presetSubtype="4" fill="hold" nodeType="clickEffect">
+                                <p:cTn id="25" presetID="22" presetClass="entr" presetSubtype="4" fill="hold" nodeType="clickEffect">
                                   <p:stCondLst>
                                     <p:cond delay="0"/>
                                   </p:stCondLst>
                                   <p:childTnLst>
                                     <p:set>
                                       <p:cBhvr>
-                                        <p:cTn id="16" dur="1" fill="hold">
+                                        <p:cTn id="26" dur="1" fill="hold">
                                           <p:stCondLst>
                                             <p:cond delay="0"/>
                                           </p:stCondLst>
@@ -27230,7 +27712,7 @@
                                     </p:set>
                                     <p:animEffect transition="in" filter="wipe(down)">
                                       <p:cBhvr>
-                                        <p:cTn id="17" dur="500"/>
+                                        <p:cTn id="27" dur="500"/>
                                         <p:tgtEl>
                                           <p:spTgt spid="10"/>
                                         </p:tgtEl>
@@ -27240,14 +27722,14 @@
                                 </p:cTn>
                               </p:par>
                               <p:par>
-                                <p:cTn id="18" presetID="22" presetClass="entr" presetSubtype="4" fill="hold" nodeType="withEffect">
+                                <p:cTn id="28" presetID="22" presetClass="entr" presetSubtype="4" fill="hold" nodeType="withEffect">
                                   <p:stCondLst>
                                     <p:cond delay="0"/>
                                   </p:stCondLst>
                                   <p:childTnLst>
                                     <p:set>
                                       <p:cBhvr>
-                                        <p:cTn id="19" dur="1" fill="hold">
+                                        <p:cTn id="29" dur="1" fill="hold">
                                           <p:stCondLst>
                                             <p:cond delay="0"/>
                                           </p:stCondLst>
@@ -27265,7 +27747,7 @@
                                     </p:set>
                                     <p:animEffect transition="in" filter="wipe(down)">
                                       <p:cBhvr>
-                                        <p:cTn id="20" dur="500"/>
+                                        <p:cTn id="30" dur="500"/>
                                         <p:tgtEl>
                                           <p:spTgt spid="18"/>
                                         </p:tgtEl>
@@ -27275,14 +27757,14 @@
                                 </p:cTn>
                               </p:par>
                               <p:par>
-                                <p:cTn id="21" presetID="22" presetClass="entr" presetSubtype="4" fill="hold" nodeType="withEffect">
+                                <p:cTn id="31" presetID="22" presetClass="entr" presetSubtype="4" fill="hold" nodeType="withEffect">
                                   <p:stCondLst>
                                     <p:cond delay="0"/>
                                   </p:stCondLst>
                                   <p:childTnLst>
                                     <p:set>
                                       <p:cBhvr>
-                                        <p:cTn id="22" dur="1" fill="hold">
+                                        <p:cTn id="32" dur="1" fill="hold">
                                           <p:stCondLst>
                                             <p:cond delay="0"/>
                                           </p:stCondLst>
@@ -27300,7 +27782,7 @@
                                     </p:set>
                                     <p:animEffect transition="in" filter="wipe(down)">
                                       <p:cBhvr>
-                                        <p:cTn id="23" dur="500"/>
+                                        <p:cTn id="33" dur="500"/>
                                         <p:tgtEl>
                                           <p:spTgt spid="24"/>
                                         </p:tgtEl>
@@ -27316,26 +27798,26 @@
                     </p:cTn>
                   </p:par>
                   <p:par>
-                    <p:cTn id="24" fill="hold">
+                    <p:cTn id="34" fill="hold">
                       <p:stCondLst>
                         <p:cond delay="indefinite"/>
                       </p:stCondLst>
                       <p:childTnLst>
                         <p:par>
-                          <p:cTn id="25" fill="hold">
+                          <p:cTn id="35" fill="hold">
                             <p:stCondLst>
                               <p:cond delay="0"/>
                             </p:stCondLst>
                             <p:childTnLst>
                               <p:par>
-                                <p:cTn id="26" presetID="22" presetClass="entr" presetSubtype="2" fill="hold" nodeType="clickEffect">
+                                <p:cTn id="36" presetID="22" presetClass="entr" presetSubtype="2" fill="hold" nodeType="clickEffect">
                                   <p:stCondLst>
                                     <p:cond delay="0"/>
                                   </p:stCondLst>
                                   <p:childTnLst>
                                     <p:set>
                                       <p:cBhvr>
-                                        <p:cTn id="27" dur="1" fill="hold">
+                                        <p:cTn id="37" dur="1" fill="hold">
                                           <p:stCondLst>
                                             <p:cond delay="0"/>
                                           </p:stCondLst>
@@ -27353,7 +27835,7 @@
                                     </p:set>
                                     <p:animEffect transition="in" filter="wipe(right)">
                                       <p:cBhvr>
-                                        <p:cTn id="28" dur="500"/>
+                                        <p:cTn id="38" dur="500"/>
                                         <p:tgtEl>
                                           <p:spTgt spid="9"/>
                                         </p:tgtEl>
@@ -27369,26 +27851,26 @@
                     </p:cTn>
                   </p:par>
                   <p:par>
-                    <p:cTn id="29" fill="hold">
+                    <p:cTn id="39" fill="hold">
                       <p:stCondLst>
                         <p:cond delay="indefinite"/>
                       </p:stCondLst>
                       <p:childTnLst>
                         <p:par>
-                          <p:cTn id="30" fill="hold">
+                          <p:cTn id="40" fill="hold">
                             <p:stCondLst>
                               <p:cond delay="0"/>
                             </p:stCondLst>
                             <p:childTnLst>
                               <p:par>
-                                <p:cTn id="31" presetID="2" presetClass="entr" presetSubtype="2" fill="hold" nodeType="clickEffect">
+                                <p:cTn id="41" presetID="2" presetClass="entr" presetSubtype="2" fill="hold" nodeType="clickEffect">
                                   <p:stCondLst>
                                     <p:cond delay="0"/>
                                   </p:stCondLst>
                                   <p:childTnLst>
                                     <p:set>
                                       <p:cBhvr>
-                                        <p:cTn id="32" dur="1" fill="hold">
+                                        <p:cTn id="42" dur="1" fill="hold">
                                           <p:stCondLst>
                                             <p:cond delay="0"/>
                                           </p:stCondLst>
@@ -27406,7 +27888,7 @@
                                     </p:set>
                                     <p:anim calcmode="lin" valueType="num">
                                       <p:cBhvr additive="base">
-                                        <p:cTn id="33" dur="500" fill="hold"/>
+                                        <p:cTn id="43" dur="500" fill="hold"/>
                                         <p:tgtEl>
                                           <p:spTgt spid="8"/>
                                         </p:tgtEl>
@@ -27429,7 +27911,7 @@
                                     </p:anim>
                                     <p:anim calcmode="lin" valueType="num">
                                       <p:cBhvr additive="base">
-                                        <p:cTn id="34" dur="500" fill="hold"/>
+                                        <p:cTn id="44" dur="500" fill="hold"/>
                                         <p:tgtEl>
                                           <p:spTgt spid="8"/>
                                         </p:tgtEl>
@@ -27457,20 +27939,20 @@
                           </p:cTn>
                         </p:par>
                         <p:par>
-                          <p:cTn id="35" fill="hold">
+                          <p:cTn id="45" fill="hold">
                             <p:stCondLst>
                               <p:cond delay="500"/>
                             </p:stCondLst>
                             <p:childTnLst>
                               <p:par>
-                                <p:cTn id="36" presetID="22" presetClass="entr" presetSubtype="2" fill="hold" nodeType="afterEffect">
+                                <p:cTn id="46" presetID="22" presetClass="entr" presetSubtype="2" fill="hold" nodeType="afterEffect">
                                   <p:stCondLst>
                                     <p:cond delay="0"/>
                                   </p:stCondLst>
                                   <p:childTnLst>
                                     <p:set>
                                       <p:cBhvr>
-                                        <p:cTn id="37" dur="1" fill="hold">
+                                        <p:cTn id="47" dur="1" fill="hold">
                                           <p:stCondLst>
                                             <p:cond delay="0"/>
                                           </p:stCondLst>
@@ -27488,7 +27970,7 @@
                                     </p:set>
                                     <p:animEffect transition="in" filter="wipe(right)">
                                       <p:cBhvr>
-                                        <p:cTn id="38" dur="500"/>
+                                        <p:cTn id="48" dur="500"/>
                                         <p:tgtEl>
                                           <p:spTgt spid="11"/>
                                         </p:tgtEl>
@@ -27526,12 +28008,14 @@
     </p:tnLst>
     <p:bldLst>
       <p:bldP spid="3" grpId="0" animBg="1"/>
+      <p:bldP spid="5" grpId="0"/>
+      <p:bldP spid="12" grpId="0" animBg="1"/>
     </p:bldLst>
   </p:timing>
 </p:sld>
 </file>
 
-<file path=ppt/slides/slide36.xml><?xml version="1.0" encoding="utf-8"?>
+<file path=ppt/slides/slide37.xml><?xml version="1.0" encoding="utf-8"?>
 <p:sld xmlns:a="http://schemas.openxmlformats.org/drawingml/2006/main" xmlns:r="http://schemas.openxmlformats.org/officeDocument/2006/relationships" xmlns:p="http://schemas.openxmlformats.org/presentationml/2006/main">
   <p:cSld>
     <p:spTree>
@@ -27771,7 +28255,7 @@
           <a:p>
             <a:fld id="{650AD656-6FF9-465D-B7B0-1CD0DD39CD23}" type="slidenum">
               <a:rPr lang="en-US" smtClean="0"/>
-              <a:t>36</a:t>
+              <a:t>37</a:t>
             </a:fld>
             <a:endParaRPr lang="en-US" dirty="0"/>
           </a:p>
@@ -28016,7 +28500,7 @@
 </p:sld>
 </file>
 
-<file path=ppt/slides/slide37.xml><?xml version="1.0" encoding="utf-8"?>
+<file path=ppt/slides/slide38.xml><?xml version="1.0" encoding="utf-8"?>
 <p:sld xmlns:a="http://schemas.openxmlformats.org/drawingml/2006/main" xmlns:r="http://schemas.openxmlformats.org/officeDocument/2006/relationships" xmlns:p="http://schemas.openxmlformats.org/presentationml/2006/main">
   <p:cSld>
     <p:spTree>
@@ -28152,7 +28636,7 @@
             <a:fld id="{650AD656-6FF9-465D-B7B0-1CD0DD39CD23}" type="slidenum">
               <a:rPr lang="en-US" smtClean="0"/>
               <a:pPr/>
-              <a:t>37</a:t>
+              <a:t>38</a:t>
             </a:fld>
             <a:endParaRPr lang="en-US"/>
           </a:p>

</xml_diff>